<commit_message>
docs(submission): 升级 Agentic 演示材料
</commit_message>
<xml_diff>
--- a/outputs/arc-paylink-pitch.pptx
+++ b/outputs/arc-paylink-pitch.pptx
@@ -2,18 +2,18 @@
 <file path=ppt/presentation.xml><?xml version="1.0" encoding="utf-8"?>
 <p:presentation xmlns:p="http://schemas.openxmlformats.org/presentationml/2006/main">
   <p:sldMasterIdLst>
-    <p:sldMasterId xmlns:r="http://schemas.openxmlformats.org/officeDocument/2006/relationships" id="2147483648" r:id="R31b3eada15c74013"/>
+    <p:sldMasterId xmlns:r="http://schemas.openxmlformats.org/officeDocument/2006/relationships" id="2147483648" r:id="R19d711c6be144832"/>
   </p:sldMasterIdLst>
   <p:notesMasterIdLst>
-    <p:notesMasterId xmlns:r="http://schemas.openxmlformats.org/officeDocument/2006/relationships" r:id="R5b8118aa70b4461a"/>
+    <p:notesMasterId xmlns:r="http://schemas.openxmlformats.org/officeDocument/2006/relationships" r:id="Raec56f053e4c4d93"/>
   </p:notesMasterIdLst>
   <p:sldIdLst>
-    <p:sldId xmlns:r="http://schemas.openxmlformats.org/officeDocument/2006/relationships" id="256" r:id="R29adb7f0d88545bb"/>
-    <p:sldId xmlns:r="http://schemas.openxmlformats.org/officeDocument/2006/relationships" id="257" r:id="Rd8f704d049d2472c"/>
-    <p:sldId xmlns:r="http://schemas.openxmlformats.org/officeDocument/2006/relationships" id="258" r:id="Rab4e5f4e9f2645b1"/>
-    <p:sldId xmlns:r="http://schemas.openxmlformats.org/officeDocument/2006/relationships" id="259" r:id="R92b11f27ea1f4462"/>
-    <p:sldId xmlns:r="http://schemas.openxmlformats.org/officeDocument/2006/relationships" id="260" r:id="R05e2ec8f8db94616"/>
-    <p:sldId xmlns:r="http://schemas.openxmlformats.org/officeDocument/2006/relationships" id="261" r:id="Rcb516b9bb0b7470e"/>
+    <p:sldId xmlns:r="http://schemas.openxmlformats.org/officeDocument/2006/relationships" id="256" r:id="Rea1ac547fdbc45e6"/>
+    <p:sldId xmlns:r="http://schemas.openxmlformats.org/officeDocument/2006/relationships" id="257" r:id="Rd0dfaa5720364b90"/>
+    <p:sldId xmlns:r="http://schemas.openxmlformats.org/officeDocument/2006/relationships" id="258" r:id="R46ef70d5d9c84765"/>
+    <p:sldId xmlns:r="http://schemas.openxmlformats.org/officeDocument/2006/relationships" id="259" r:id="R386234b5ebab40c3"/>
+    <p:sldId xmlns:r="http://schemas.openxmlformats.org/officeDocument/2006/relationships" id="260" r:id="R67fef0aae7d84858"/>
+    <p:sldId xmlns:r="http://schemas.openxmlformats.org/officeDocument/2006/relationships" id="261" r:id="R2708ba7af7464f71"/>
   </p:sldIdLst>
   <p:sldSz cx="12192000" cy="6858000"/>
   <p:notesSz cx="6858000" cy="9144000"/>
@@ -936,7 +936,7 @@
   </p:cSld>
   <p:clrMap bg1="lt1" tx1="dk1" bg2="lt2" tx2="dk2" accent1="accent1" accent2="accent2" accent3="accent3" accent4="accent4" accent5="accent5" accent6="accent6" hlink="hlink" folHlink="folHlink"/>
   <p:sldLayoutIdLst>
-    <p:sldLayoutId xmlns:r="http://schemas.openxmlformats.org/officeDocument/2006/relationships" id="2147483649" r:id="R854c1acff5ae445a"/>
+    <p:sldLayoutId xmlns:r="http://schemas.openxmlformats.org/officeDocument/2006/relationships" id="2147483649" r:id="R84bf3db6fee04cba"/>
   </p:sldLayoutIdLst>
   <p:txStyles>
     <p:titleStyle>
@@ -1484,7 +1484,7 @@
       </p:grpSpPr>
       <p:sp>
         <p:nvSpPr>
-          <p:cNvPr id="1" name="">
+          <p:cNvPr id="4" name="">
             <a:extLst xmlns:a="http://schemas.openxmlformats.org/drawingml/2006/main">
               <a:ext uri="{FF2B5EF4-FFF2-40B4-BE49-F238E27FC236}">
                 <a16:creationId xmlns:a16="http://schemas.microsoft.com/office/drawing/2014/main" id="{40FCE348-BF08-4266-9192-E3F83AEDD4BE}"/>
@@ -1514,6 +1514,7 @@
           <a:lstStyle xmlns:a="http://schemas.openxmlformats.org/drawingml/2006/main"/>
           <a:p xmlns:a="http://schemas.openxmlformats.org/drawingml/2006/main">
             <a:pPr>
+              <a:buNone/>
               <a:defRPr sz="1800" b="0">
                 <a:solidFill>
                   <a:srgbClr val="07110D"/>
@@ -1532,7 +1533,7 @@
                 <a:ea typeface="Helvetica Neue"/>
                 <a:cs typeface="Helvetica Neue"/>
               </a:rPr>
-              <a:t>ARC PROGRAMMABLE MONEY</a:t>
+              <a:t>ARC AGENTIC ECONOMY</a:t>
             </a:r>
           </a:p>
         </p:txBody>
@@ -1569,6 +1570,7 @@
           <a:lstStyle xmlns:a="http://schemas.openxmlformats.org/drawingml/2006/main"/>
           <a:p xmlns:a="http://schemas.openxmlformats.org/drawingml/2006/main">
             <a:pPr>
+              <a:buNone/>
               <a:defRPr sz="5400" b="1">
                 <a:solidFill>
                   <a:srgbClr val="07110D"/>
@@ -1592,6 +1594,7 @@
           </a:p>
           <a:p xmlns:a="http://schemas.openxmlformats.org/drawingml/2006/main">
             <a:pPr>
+              <a:buNone/>
               <a:defRPr sz="5400" b="1">
                 <a:solidFill>
                   <a:srgbClr val="07110D"/>
@@ -1610,7 +1613,7 @@
                 <a:ea typeface="Helvetica Neue"/>
                 <a:cs typeface="Helvetica Neue"/>
               </a:rPr>
-              <a:t>Programmable USDC invoices</a:t>
+              <a:t>Verifiable autonomous USDC settlement</a:t>
             </a:r>
           </a:p>
         </p:txBody>
@@ -1647,6 +1650,7 @@
           <a:lstStyle xmlns:a="http://schemas.openxmlformats.org/drawingml/2006/main"/>
           <a:p xmlns:a="http://schemas.openxmlformats.org/drawingml/2006/main">
             <a:pPr>
+              <a:buNone/>
               <a:defRPr sz="1950" b="0">
                 <a:solidFill>
                   <a:srgbClr val="07110D"/>
@@ -1665,7 +1669,7 @@
                 <a:ea typeface="Helvetica Neue"/>
                 <a:cs typeface="Helvetica Neue"/>
               </a:rPr>
-              <a:t>Direct settlement or delivery-protected escrow — without giving up wallet custody.</a:t>
+              <a:t>An Arc agent can identify itself, enforce policy, settle work and pay for machine-readable proof.</a:t>
             </a:r>
           </a:p>
         </p:txBody>
@@ -1701,7 +1705,7 @@
       </p:grpSpPr>
       <p:sp>
         <p:nvSpPr>
-          <p:cNvPr id="1" name="">
+          <p:cNvPr id="9" name="">
             <a:extLst xmlns:a="http://schemas.openxmlformats.org/drawingml/2006/main">
               <a:ext uri="{FF2B5EF4-FFF2-40B4-BE49-F238E27FC236}">
                 <a16:creationId xmlns:a16="http://schemas.microsoft.com/office/drawing/2014/main" id="{C90FA1DF-A3C5-439D-8B63-767A5872E5FB}"/>
@@ -1731,6 +1735,7 @@
           <a:lstStyle xmlns:a="http://schemas.openxmlformats.org/drawingml/2006/main"/>
           <a:p xmlns:a="http://schemas.openxmlformats.org/drawingml/2006/main">
             <a:pPr>
+              <a:buNone/>
               <a:defRPr sz="2925" b="1">
                 <a:solidFill>
                   <a:srgbClr val="07110D"/>
@@ -1749,7 +1754,7 @@
                 <a:ea typeface="Helvetica Neue"/>
                 <a:cs typeface="Helvetica Neue"/>
               </a:rPr>
-              <a:t>A wallet address is not an invoice</a:t>
+              <a:t>Autonomous payments need more than a wallet</a:t>
             </a:r>
           </a:p>
         </p:txBody>
@@ -1786,6 +1791,7 @@
           <a:lstStyle xmlns:a="http://schemas.openxmlformats.org/drawingml/2006/main"/>
           <a:p xmlns:a="http://schemas.openxmlformats.org/drawingml/2006/main">
             <a:pPr>
+              <a:buNone/>
               <a:defRPr sz="975" b="0">
                 <a:solidFill>
                   <a:srgbClr val="07110D"/>
@@ -1843,6 +1849,7 @@
           <a:lstStyle xmlns:a="http://schemas.openxmlformats.org/drawingml/2006/main"/>
           <a:p xmlns:a="http://schemas.openxmlformats.org/drawingml/2006/main">
             <a:pPr>
+              <a:buNone/>
               <a:defRPr sz="2250" b="1">
                 <a:solidFill>
                   <a:srgbClr val="07110D"/>
@@ -1861,7 +1868,7 @@
                 <a:ea typeface="Helvetica Neue"/>
                 <a:cs typeface="Helvetica Neue"/>
               </a:rPr>
-              <a:t>No context</a:t>
+              <a:t>Identity</a:t>
             </a:r>
           </a:p>
         </p:txBody>
@@ -1898,6 +1905,7 @@
           <a:lstStyle xmlns:a="http://schemas.openxmlformats.org/drawingml/2006/main"/>
           <a:p xmlns:a="http://schemas.openxmlformats.org/drawingml/2006/main">
             <a:pPr>
+              <a:buNone/>
               <a:defRPr sz="1575" b="0">
                 <a:solidFill>
                   <a:srgbClr val="07110D"/>
@@ -1916,7 +1924,7 @@
                 <a:ea typeface="Helvetica Neue"/>
                 <a:cs typeface="Helvetica Neue"/>
               </a:rPr>
-              <a:t>Amount, purpose and order details live outside the payment.</a:t>
+              <a:t>Who paid, which policy governed it, and what agent can be held accountable?</a:t>
             </a:r>
           </a:p>
         </p:txBody>
@@ -1955,6 +1963,7 @@
           <a:lstStyle xmlns:a="http://schemas.openxmlformats.org/drawingml/2006/main"/>
           <a:p xmlns:a="http://schemas.openxmlformats.org/drawingml/2006/main">
             <a:pPr>
+              <a:buNone/>
               <a:defRPr sz="2250" b="1">
                 <a:solidFill>
                   <a:srgbClr val="07110D"/>
@@ -1973,7 +1982,7 @@
                 <a:ea typeface="Helvetica Neue"/>
                 <a:cs typeface="Helvetica Neue"/>
               </a:rPr>
-              <a:t>No condition</a:t>
+              <a:t>Execution</a:t>
             </a:r>
           </a:p>
         </p:txBody>
@@ -2010,6 +2019,7 @@
           <a:lstStyle xmlns:a="http://schemas.openxmlformats.org/drawingml/2006/main"/>
           <a:p xmlns:a="http://schemas.openxmlformats.org/drawingml/2006/main">
             <a:pPr>
+              <a:buNone/>
               <a:defRPr sz="1575" b="0">
                 <a:solidFill>
                   <a:srgbClr val="07110D"/>
@@ -2028,7 +2038,7 @@
                 <a:ea typeface="Helvetica Neue"/>
                 <a:cs typeface="Helvetica Neue"/>
               </a:rPr>
-              <a:t>Payment cannot wait for delivery or enforce a refund window.</a:t>
+              <a:t>Can an agent spend without exceeding recipient, amount, time and replay limits?</a:t>
             </a:r>
           </a:p>
         </p:txBody>
@@ -2067,6 +2077,7 @@
           <a:lstStyle xmlns:a="http://schemas.openxmlformats.org/drawingml/2006/main"/>
           <a:p xmlns:a="http://schemas.openxmlformats.org/drawingml/2006/main">
             <a:pPr>
+              <a:buNone/>
               <a:defRPr sz="2250" b="1">
                 <a:solidFill>
                   <a:srgbClr val="07110D"/>
@@ -2085,7 +2096,7 @@
                 <a:ea typeface="Helvetica Neue"/>
                 <a:cs typeface="Helvetica Neue"/>
               </a:rPr>
-              <a:t>More trust</a:t>
+              <a:t>Proof</a:t>
             </a:r>
           </a:p>
         </p:txBody>
@@ -2122,6 +2133,7 @@
           <a:lstStyle xmlns:a="http://schemas.openxmlformats.org/drawingml/2006/main"/>
           <a:p xmlns:a="http://schemas.openxmlformats.org/drawingml/2006/main">
             <a:pPr>
+              <a:buNone/>
               <a:defRPr sz="1575" b="0">
                 <a:solidFill>
                   <a:srgbClr val="07110D"/>
@@ -2140,7 +2152,7 @@
                 <a:ea typeface="Helvetica Neue"/>
                 <a:cs typeface="Helvetica Neue"/>
               </a:rPr>
-              <a:t>Custodial platforms add accounts, approvals and key-management risk.</a:t>
+              <a:t>Did the job settle, and can another machine verify the result before paying?</a:t>
             </a:r>
           </a:p>
         </p:txBody>
@@ -2176,7 +2188,7 @@
       </p:grpSpPr>
       <p:sp>
         <p:nvSpPr>
-          <p:cNvPr id="1" name="">
+          <p:cNvPr id="13" name="">
             <a:extLst xmlns:a="http://schemas.openxmlformats.org/drawingml/2006/main">
               <a:ext uri="{FF2B5EF4-FFF2-40B4-BE49-F238E27FC236}">
                 <a16:creationId xmlns:a16="http://schemas.microsoft.com/office/drawing/2014/main" id="{89DA6DEE-A205-40B6-B404-F59A61DBD4B7}"/>
@@ -2206,6 +2218,7 @@
           <a:lstStyle xmlns:a="http://schemas.openxmlformats.org/drawingml/2006/main"/>
           <a:p xmlns:a="http://schemas.openxmlformats.org/drawingml/2006/main">
             <a:pPr>
+              <a:buNone/>
               <a:defRPr sz="2925" b="1">
                 <a:solidFill>
                   <a:srgbClr val="07110D"/>
@@ -2224,7 +2237,7 @@
                 <a:ea typeface="Helvetica Neue"/>
                 <a:cs typeface="Helvetica Neue"/>
               </a:rPr>
-              <a:t>One link carries payment context and settlement rules</a:t>
+              <a:t>One agent closes the work-to-payment loop</a:t>
             </a:r>
           </a:p>
         </p:txBody>
@@ -2261,6 +2274,7 @@
           <a:lstStyle xmlns:a="http://schemas.openxmlformats.org/drawingml/2006/main"/>
           <a:p xmlns:a="http://schemas.openxmlformats.org/drawingml/2006/main">
             <a:pPr>
+              <a:buNone/>
               <a:defRPr sz="975" b="0">
                 <a:solidFill>
                   <a:srgbClr val="07110D"/>
@@ -2348,6 +2362,7 @@
           <a:lstStyle xmlns:a="http://schemas.openxmlformats.org/drawingml/2006/main"/>
           <a:p xmlns:a="http://schemas.openxmlformats.org/drawingml/2006/main">
             <a:pPr>
+              <a:buNone/>
               <a:defRPr sz="1650" b="1">
                 <a:solidFill>
                   <a:srgbClr val="07110D"/>
@@ -2403,6 +2418,7 @@
           <a:lstStyle xmlns:a="http://schemas.openxmlformats.org/drawingml/2006/main"/>
           <a:p xmlns:a="http://schemas.openxmlformats.org/drawingml/2006/main">
             <a:pPr>
+              <a:buNone/>
               <a:defRPr sz="2250" b="1">
                 <a:solidFill>
                   <a:srgbClr val="07110D"/>
@@ -2421,7 +2437,7 @@
                 <a:ea typeface="Helvetica Neue"/>
                 <a:cs typeface="Helvetica Neue"/>
               </a:rPr>
-              <a:t>Create</a:t>
+              <a:t>Identify</a:t>
             </a:r>
           </a:p>
         </p:txBody>
@@ -2458,6 +2474,7 @@
           <a:lstStyle xmlns:a="http://schemas.openxmlformats.org/drawingml/2006/main"/>
           <a:p xmlns:a="http://schemas.openxmlformats.org/drawingml/2006/main">
             <a:pPr>
+              <a:buNone/>
               <a:defRPr sz="1500" b="0">
                 <a:solidFill>
                   <a:srgbClr val="07110D"/>
@@ -2476,7 +2493,7 @@
                 <a:ea typeface="Helvetica Neue"/>
                 <a:cs typeface="Helvetica Neue"/>
               </a:rPr>
-              <a:t>Recipient, amount, note and mode</a:t>
+              <a:t>ERC-8004 Agent #851241</a:t>
             </a:r>
           </a:p>
         </p:txBody>
@@ -2515,6 +2532,7 @@
           <a:lstStyle xmlns:a="http://schemas.openxmlformats.org/drawingml/2006/main"/>
           <a:p xmlns:a="http://schemas.openxmlformats.org/drawingml/2006/main">
             <a:pPr>
+              <a:buNone/>
               <a:defRPr sz="1650" b="1">
                 <a:solidFill>
                   <a:srgbClr val="07110D"/>
@@ -2570,6 +2588,7 @@
           <a:lstStyle xmlns:a="http://schemas.openxmlformats.org/drawingml/2006/main"/>
           <a:p xmlns:a="http://schemas.openxmlformats.org/drawingml/2006/main">
             <a:pPr>
+              <a:buNone/>
               <a:defRPr sz="2250" b="1">
                 <a:solidFill>
                   <a:srgbClr val="07110D"/>
@@ -2588,7 +2607,7 @@
                 <a:ea typeface="Helvetica Neue"/>
                 <a:cs typeface="Helvetica Neue"/>
               </a:rPr>
-              <a:t>Fund</a:t>
+              <a:t>Settle</a:t>
             </a:r>
           </a:p>
         </p:txBody>
@@ -2625,6 +2644,7 @@
           <a:lstStyle xmlns:a="http://schemas.openxmlformats.org/drawingml/2006/main"/>
           <a:p xmlns:a="http://schemas.openxmlformats.org/drawingml/2006/main">
             <a:pPr>
+              <a:buNone/>
               <a:defRPr sz="1500" b="0">
                 <a:solidFill>
                   <a:srgbClr val="07110D"/>
@@ -2643,7 +2663,7 @@
                 <a:ea typeface="Helvetica Neue"/>
                 <a:cs typeface="Helvetica Neue"/>
               </a:rPr>
-              <a:t>Wallet signs native USDC on Arc</a:t>
+              <a:t>ERC-8183 Job #158446</a:t>
             </a:r>
           </a:p>
         </p:txBody>
@@ -2682,6 +2702,7 @@
           <a:lstStyle xmlns:a="http://schemas.openxmlformats.org/drawingml/2006/main"/>
           <a:p xmlns:a="http://schemas.openxmlformats.org/drawingml/2006/main">
             <a:pPr>
+              <a:buNone/>
               <a:defRPr sz="1650" b="1">
                 <a:solidFill>
                   <a:srgbClr val="07110D"/>
@@ -2737,6 +2758,7 @@
           <a:lstStyle xmlns:a="http://schemas.openxmlformats.org/drawingml/2006/main"/>
           <a:p xmlns:a="http://schemas.openxmlformats.org/drawingml/2006/main">
             <a:pPr>
+              <a:buNone/>
               <a:defRPr sz="2250" b="1">
                 <a:solidFill>
                   <a:srgbClr val="07110D"/>
@@ -2755,7 +2777,7 @@
                 <a:ea typeface="Helvetica Neue"/>
                 <a:cs typeface="Helvetica Neue"/>
               </a:rPr>
-              <a:t>Settle</a:t>
+              <a:t>Verify + pay</a:t>
             </a:r>
           </a:p>
         </p:txBody>
@@ -2792,6 +2814,7 @@
           <a:lstStyle xmlns:a="http://schemas.openxmlformats.org/drawingml/2006/main"/>
           <a:p xmlns:a="http://schemas.openxmlformats.org/drawingml/2006/main">
             <a:pPr>
+              <a:buNone/>
               <a:defRPr sz="1500" b="0">
                 <a:solidFill>
                   <a:srgbClr val="07110D"/>
@@ -2810,7 +2833,7 @@
                 <a:ea typeface="Helvetica Neue"/>
                 <a:cs typeface="Helvetica Neue"/>
               </a:rPr>
-              <a:t>Release after delivery or refund at expiry</a:t>
+              <a:t>x402 signal for 0.01 USDC</a:t>
             </a:r>
           </a:p>
         </p:txBody>
@@ -2846,7 +2869,7 @@
       </p:grpSpPr>
       <p:sp>
         <p:nvSpPr>
-          <p:cNvPr id="1" name="">
+          <p:cNvPr id="10" name="">
             <a:extLst xmlns:a="http://schemas.openxmlformats.org/drawingml/2006/main">
               <a:ext uri="{FF2B5EF4-FFF2-40B4-BE49-F238E27FC236}">
                 <a16:creationId xmlns:a16="http://schemas.microsoft.com/office/drawing/2014/main" id="{FBA5964D-DDAD-46F7-913E-12406B26AF8C}"/>
@@ -2876,6 +2899,7 @@
           <a:lstStyle xmlns:a="http://schemas.openxmlformats.org/drawingml/2006/main"/>
           <a:p xmlns:a="http://schemas.openxmlformats.org/drawingml/2006/main">
             <a:pPr>
+              <a:buNone/>
               <a:defRPr sz="2925" b="1">
                 <a:solidFill>
                   <a:srgbClr val="07110D"/>
@@ -2894,7 +2918,7 @@
                 <a:ea typeface="Helvetica Neue"/>
                 <a:cs typeface="Helvetica Neue"/>
               </a:rPr>
-              <a:t>Arc makes the payment and the program share one currency</a:t>
+              <a:t>Arc and Circle make the autonomous loop composable</a:t>
             </a:r>
           </a:p>
         </p:txBody>
@@ -2931,6 +2955,7 @@
           <a:lstStyle xmlns:a="http://schemas.openxmlformats.org/drawingml/2006/main"/>
           <a:p xmlns:a="http://schemas.openxmlformats.org/drawingml/2006/main">
             <a:pPr>
+              <a:buNone/>
               <a:defRPr sz="975" b="0">
                 <a:solidFill>
                   <a:srgbClr val="07110D"/>
@@ -2988,6 +3013,7 @@
           <a:lstStyle xmlns:a="http://schemas.openxmlformats.org/drawingml/2006/main"/>
           <a:p xmlns:a="http://schemas.openxmlformats.org/drawingml/2006/main">
             <a:pPr>
+              <a:buNone/>
               <a:defRPr sz="2100" b="1">
                 <a:solidFill>
                   <a:srgbClr val="07110D"/>
@@ -3006,7 +3032,7 @@
                 <a:ea typeface="Helvetica Neue"/>
                 <a:cs typeface="Helvetica Neue"/>
               </a:rPr>
-              <a:t>Browser wallet</a:t>
+              <a:t>Policy Vault</a:t>
             </a:r>
           </a:p>
         </p:txBody>
@@ -3045,6 +3071,7 @@
           <a:lstStyle xmlns:a="http://schemas.openxmlformats.org/drawingml/2006/main"/>
           <a:p xmlns:a="http://schemas.openxmlformats.org/drawingml/2006/main">
             <a:pPr>
+              <a:buNone/>
               <a:defRPr sz="2100" b="1">
                 <a:solidFill>
                   <a:srgbClr val="07110D"/>
@@ -3063,7 +3090,7 @@
                 <a:ea typeface="Helvetica Neue"/>
                 <a:cs typeface="Helvetica Neue"/>
               </a:rPr>
-              <a:t>Arc Paylink</a:t>
+              <a:t>Arc contracts</a:t>
             </a:r>
           </a:p>
         </p:txBody>
@@ -3102,6 +3129,7 @@
           <a:lstStyle xmlns:a="http://schemas.openxmlformats.org/drawingml/2006/main"/>
           <a:p xmlns:a="http://schemas.openxmlformats.org/drawingml/2006/main">
             <a:pPr>
+              <a:buNone/>
               <a:defRPr sz="2100" b="1">
                 <a:solidFill>
                   <a:srgbClr val="07110D"/>
@@ -3120,7 +3148,7 @@
                 <a:ea typeface="Helvetica Neue"/>
                 <a:cs typeface="Helvetica Neue"/>
               </a:rPr>
-              <a:t>Escrow contract</a:t>
+              <a:t>Circle Gateway</a:t>
             </a:r>
           </a:p>
         </p:txBody>
@@ -3157,6 +3185,7 @@
           <a:lstStyle xmlns:a="http://schemas.openxmlformats.org/drawingml/2006/main"/>
           <a:p xmlns:a="http://schemas.openxmlformats.org/drawingml/2006/main">
             <a:pPr>
+              <a:buNone/>
               <a:defRPr sz="1500" b="0">
                 <a:solidFill>
                   <a:srgbClr val="07110D"/>
@@ -3175,7 +3204,7 @@
                 <a:ea typeface="Helvetica Neue"/>
                 <a:cs typeface="Helvetica Neue"/>
               </a:rPr>
-              <a:t>Signs every transaction</a:t>
+              <a:t>Caps spend + blocks replay</a:t>
             </a:r>
           </a:p>
         </p:txBody>
@@ -3212,6 +3241,7 @@
           <a:lstStyle xmlns:a="http://schemas.openxmlformats.org/drawingml/2006/main"/>
           <a:p xmlns:a="http://schemas.openxmlformats.org/drawingml/2006/main">
             <a:pPr>
+              <a:buNone/>
               <a:defRPr sz="1500" b="0">
                 <a:solidFill>
                   <a:srgbClr val="07110D"/>
@@ -3230,7 +3260,7 @@
                 <a:ea typeface="Helvetica Neue"/>
                 <a:cs typeface="Helvetica Neue"/>
               </a:rPr>
-              <a:t>Encodes invoice context</a:t>
+              <a:t>Identity + job settlement</a:t>
             </a:r>
           </a:p>
         </p:txBody>
@@ -3267,6 +3297,7 @@
           <a:lstStyle xmlns:a="http://schemas.openxmlformats.org/drawingml/2006/main"/>
           <a:p xmlns:a="http://schemas.openxmlformats.org/drawingml/2006/main">
             <a:pPr>
+              <a:buNone/>
               <a:defRPr sz="1500" b="0">
                 <a:solidFill>
                   <a:srgbClr val="07110D"/>
@@ -3285,7 +3316,7 @@
                 <a:ea typeface="Helvetica Neue"/>
                 <a:cs typeface="Helvetica Neue"/>
               </a:rPr>
-              <a:t>Holds native USDC</a:t>
+              <a:t>Gasless x402 nanopayment</a:t>
             </a:r>
           </a:p>
         </p:txBody>
@@ -3322,6 +3353,7 @@
           <a:lstStyle xmlns:a="http://schemas.openxmlformats.org/drawingml/2006/main"/>
           <a:p xmlns:a="http://schemas.openxmlformats.org/drawingml/2006/main">
             <a:pPr>
+              <a:buNone/>
               <a:defRPr sz="1875" b="1">
                 <a:solidFill>
                   <a:srgbClr val="07110D"/>
@@ -3340,7 +3372,7 @@
                 <a:ea typeface="Helvetica Neue"/>
                 <a:cs typeface="Helvetica Neue"/>
               </a:rPr>
-              <a:t>USDC is both the settlement asset and Arc’s native gas token.</a:t>
+              <a:t>USDC is the budget, escrow asset, payout and machine-payment currency.</a:t>
             </a:r>
           </a:p>
         </p:txBody>
@@ -3376,7 +3408,7 @@
       </p:grpSpPr>
       <p:sp>
         <p:nvSpPr>
-          <p:cNvPr id="1" name="">
+          <p:cNvPr id="10" name="">
             <a:extLst xmlns:a="http://schemas.openxmlformats.org/drawingml/2006/main">
               <a:ext uri="{FF2B5EF4-FFF2-40B4-BE49-F238E27FC236}">
                 <a16:creationId xmlns:a16="http://schemas.microsoft.com/office/drawing/2014/main" id="{78E8065F-B7C7-48B4-9893-07FDCD26CA01}"/>
@@ -3406,6 +3438,7 @@
           <a:lstStyle xmlns:a="http://schemas.openxmlformats.org/drawingml/2006/main"/>
           <a:p xmlns:a="http://schemas.openxmlformats.org/drawingml/2006/main">
             <a:pPr>
+              <a:buNone/>
               <a:defRPr sz="2925" b="1">
                 <a:solidFill>
                   <a:srgbClr val="07110D"/>
@@ -3424,7 +3457,7 @@
                 <a:ea typeface="Helvetica Neue"/>
                 <a:cs typeface="Helvetica Neue"/>
               </a:rPr>
-              <a:t>The MVP is live and independently verifiable</a:t>
+              <a:t>Every critical claim already has public evidence</a:t>
             </a:r>
           </a:p>
         </p:txBody>
@@ -3461,6 +3494,7 @@
           <a:lstStyle xmlns:a="http://schemas.openxmlformats.org/drawingml/2006/main"/>
           <a:p xmlns:a="http://schemas.openxmlformats.org/drawingml/2006/main">
             <a:pPr>
+              <a:buNone/>
               <a:defRPr sz="975" b="0">
                 <a:solidFill>
                   <a:srgbClr val="07110D"/>
@@ -3518,6 +3552,7 @@
           <a:lstStyle xmlns:a="http://schemas.openxmlformats.org/drawingml/2006/main"/>
           <a:p xmlns:a="http://schemas.openxmlformats.org/drawingml/2006/main">
             <a:pPr>
+              <a:buNone/>
               <a:defRPr sz="2850" b="1">
                 <a:solidFill>
                   <a:srgbClr val="07110D"/>
@@ -3536,7 +3571,7 @@
                 <a:ea typeface="Helvetica Neue"/>
                 <a:cs typeface="Helvetica Neue"/>
               </a:rPr>
-              <a:t>LIVE</a:t>
+              <a:t>851241</a:t>
             </a:r>
           </a:p>
         </p:txBody>
@@ -3573,6 +3608,7 @@
           <a:lstStyle xmlns:a="http://schemas.openxmlformats.org/drawingml/2006/main"/>
           <a:p xmlns:a="http://schemas.openxmlformats.org/drawingml/2006/main">
             <a:pPr>
+              <a:buNone/>
               <a:defRPr sz="1575" b="0">
                 <a:solidFill>
                   <a:srgbClr val="07110D"/>
@@ -3591,7 +3627,7 @@
                 <a:ea typeface="Helvetica Neue"/>
                 <a:cs typeface="Helvetica Neue"/>
               </a:rPr>
-              <a:t>Public HTTPS app</a:t>
+              <a:t>ERC-8004 agent identity</a:t>
             </a:r>
           </a:p>
         </p:txBody>
@@ -3630,6 +3666,7 @@
           <a:lstStyle xmlns:a="http://schemas.openxmlformats.org/drawingml/2006/main"/>
           <a:p xmlns:a="http://schemas.openxmlformats.org/drawingml/2006/main">
             <a:pPr>
+              <a:buNone/>
               <a:defRPr sz="2850" b="1">
                 <a:solidFill>
                   <a:srgbClr val="07110D"/>
@@ -3648,7 +3685,7 @@
                 <a:ea typeface="Helvetica Neue"/>
                 <a:cs typeface="Helvetica Neue"/>
               </a:rPr>
-              <a:t>OPEN</a:t>
+              <a:t>158446</a:t>
             </a:r>
           </a:p>
         </p:txBody>
@@ -3685,6 +3722,7 @@
           <a:lstStyle xmlns:a="http://schemas.openxmlformats.org/drawingml/2006/main"/>
           <a:p xmlns:a="http://schemas.openxmlformats.org/drawingml/2006/main">
             <a:pPr>
+              <a:buNone/>
               <a:defRPr sz="1575" b="0">
                 <a:solidFill>
                   <a:srgbClr val="07110D"/>
@@ -3703,7 +3741,7 @@
                 <a:ea typeface="Helvetica Neue"/>
                 <a:cs typeface="Helvetica Neue"/>
               </a:rPr>
-              <a:t>GitHub source</a:t>
+              <a:t>ERC-8183 job completed</a:t>
             </a:r>
           </a:p>
         </p:txBody>
@@ -3742,6 +3780,7 @@
           <a:lstStyle xmlns:a="http://schemas.openxmlformats.org/drawingml/2006/main"/>
           <a:p xmlns:a="http://schemas.openxmlformats.org/drawingml/2006/main">
             <a:pPr>
+              <a:buNone/>
               <a:defRPr sz="2850" b="1">
                 <a:solidFill>
                   <a:srgbClr val="07110D"/>
@@ -3760,7 +3799,7 @@
                 <a:ea typeface="Helvetica Neue"/>
                 <a:cs typeface="Helvetica Neue"/>
               </a:rPr>
-              <a:t>ONCHAIN</a:t>
+              <a:t>$0.01</a:t>
             </a:r>
           </a:p>
         </p:txBody>
@@ -3797,6 +3836,7 @@
           <a:lstStyle xmlns:a="http://schemas.openxmlformats.org/drawingml/2006/main"/>
           <a:p xmlns:a="http://schemas.openxmlformats.org/drawingml/2006/main">
             <a:pPr>
+              <a:buNone/>
               <a:defRPr sz="1575" b="0">
                 <a:solidFill>
                   <a:srgbClr val="07110D"/>
@@ -3815,7 +3855,7 @@
                 <a:ea typeface="Helvetica Neue"/>
                 <a:cs typeface="Helvetica Neue"/>
               </a:rPr>
-              <a:t>Fund + release proven</a:t>
+              <a:t>x402 paid · HTTP 200</a:t>
             </a:r>
           </a:p>
         </p:txBody>
@@ -3852,6 +3892,7 @@
           <a:lstStyle xmlns:a="http://schemas.openxmlformats.org/drawingml/2006/main"/>
           <a:p xmlns:a="http://schemas.openxmlformats.org/drawingml/2006/main">
             <a:pPr>
+              <a:buNone/>
               <a:defRPr sz="1500" b="0">
                 <a:solidFill>
                   <a:srgbClr val="07110D"/>
@@ -3870,7 +3911,7 @@
                 <a:ea typeface="Helvetica Neue"/>
                 <a:cs typeface="Helvetica Neue"/>
               </a:rPr>
-              <a:t>Contract  0xcc5a…6c4d  •  Arc Testnet</a:t>
+              <a:t>Arc Testnet  •  public app  •  source  •  transactions  •  JSON proof</a:t>
             </a:r>
           </a:p>
         </p:txBody>
@@ -3906,7 +3947,7 @@
       </p:grpSpPr>
       <p:sp>
         <p:nvSpPr>
-          <p:cNvPr id="1" name="">
+          <p:cNvPr id="4" name="">
             <a:extLst xmlns:a="http://schemas.openxmlformats.org/drawingml/2006/main">
               <a:ext uri="{FF2B5EF4-FFF2-40B4-BE49-F238E27FC236}">
                 <a16:creationId xmlns:a16="http://schemas.microsoft.com/office/drawing/2014/main" id="{C11052D4-C1C6-4F83-8FF6-43FEFCF39D52}"/>
@@ -3936,6 +3977,7 @@
           <a:lstStyle xmlns:a="http://schemas.openxmlformats.org/drawingml/2006/main"/>
           <a:p xmlns:a="http://schemas.openxmlformats.org/drawingml/2006/main">
             <a:pPr>
+              <a:buNone/>
               <a:defRPr sz="1800" b="1">
                 <a:solidFill>
                   <a:srgbClr val="07110D"/>
@@ -3954,7 +3996,7 @@
                 <a:ea typeface="Helvetica Neue"/>
                 <a:cs typeface="Helvetica Neue"/>
               </a:rPr>
-              <a:t>NEXT</a:t>
+              <a:t>THE RESULT</a:t>
             </a:r>
           </a:p>
         </p:txBody>
@@ -3991,6 +4033,7 @@
           <a:lstStyle xmlns:a="http://schemas.openxmlformats.org/drawingml/2006/main"/>
           <a:p xmlns:a="http://schemas.openxmlformats.org/drawingml/2006/main">
             <a:pPr>
+              <a:buNone/>
               <a:defRPr sz="5100" b="1">
                 <a:solidFill>
                   <a:srgbClr val="07110D"/>
@@ -4009,11 +4052,12 @@
                 <a:ea typeface="Helvetica Neue"/>
                 <a:cs typeface="Helvetica Neue"/>
               </a:rPr>
-              <a:t>Make protected USDC settlement</a:t>
-            </a:r>
-          </a:p>
-          <a:p xmlns:a="http://schemas.openxmlformats.org/drawingml/2006/main">
-            <a:pPr>
+              <a:t>A bounded agent can turn</a:t>
+            </a:r>
+          </a:p>
+          <a:p xmlns:a="http://schemas.openxmlformats.org/drawingml/2006/main">
+            <a:pPr>
+              <a:buNone/>
               <a:defRPr sz="5100" b="1">
                 <a:solidFill>
                   <a:srgbClr val="07110D"/>
@@ -4032,7 +4076,7 @@
                 <a:ea typeface="Helvetica Neue"/>
                 <a:cs typeface="Helvetica Neue"/>
               </a:rPr>
-              <a:t>as easy to share as a link.</a:t>
+              <a:t>verified work into USDC settlement.</a:t>
             </a:r>
           </a:p>
         </p:txBody>
@@ -4069,6 +4113,7 @@
           <a:lstStyle xmlns:a="http://schemas.openxmlformats.org/drawingml/2006/main"/>
           <a:p xmlns:a="http://schemas.openxmlformats.org/drawingml/2006/main">
             <a:pPr>
+              <a:buNone/>
               <a:defRPr sz="1800" b="0">
                 <a:solidFill>
                   <a:srgbClr val="07110D"/>
@@ -4092,6 +4137,7 @@
           </a:p>
           <a:p xmlns:a="http://schemas.openxmlformats.org/drawingml/2006/main">
             <a:pPr>
+              <a:buNone/>
               <a:defRPr sz="1800" b="0">
                 <a:solidFill>
                   <a:srgbClr val="07110D"/>

</xml_diff>